<commit_message>
Fix the stretched screenshot and draw real iPhone frames
The dashboard image is 2880x1800 - a 1.600 ratio - but it had been placed in
a 14.5 x 5.55 box, which is 2.613. It was stretched 63 percent horizontally.
The screen box is now derived from the source ratio rather than chosen to fill
the slide, so nothing is distorted, and the laptop gained a base and notch.

The phone shots were in plain rounded rectangles. They now sit in drawn iPhone
frames - titanium band, black bezel, Dynamic Island and side buttons - at the
true 0.462 ratio of a 1170x2532 screenshot. The island sits in the bezel above
the glass rather than over it, which was hiding the app's own header.
</commit_message>
<xml_diff>
--- a/Khoroch-LSH26-T033-P12.pptx
+++ b/Khoroch-LSH26-T033-P12.pptx
@@ -11215,12 +11215,12 @@
         </p:nvSpPr>
         <p:spPr>
           <a:xfrm>
-            <a:off x="2331720" y="3337560"/>
-            <a:ext cx="13624560" cy="5440680"/>
+            <a:off x="4736592" y="3502152"/>
+            <a:ext cx="8814816" cy="5660136"/>
           </a:xfrm>
           <a:prstGeom prst="roundRect">
             <a:avLst>
-              <a:gd name="adj" fmla="val 2353"/>
+              <a:gd name="adj" fmla="val 969"/>
             </a:avLst>
           </a:prstGeom>
           <a:solidFill>
@@ -11245,8 +11245,8 @@
         </p:blipFill>
         <p:spPr>
           <a:xfrm>
-            <a:off x="2514600" y="3520440"/>
-            <a:ext cx="13258800" cy="5074920"/>
+            <a:off x="4937760" y="3703320"/>
+            <a:ext cx="8412480" cy="5257800"/>
           </a:xfrm>
           <a:prstGeom prst="rect">
             <a:avLst/>
@@ -11261,8 +11261,8 @@
         </p:nvSpPr>
         <p:spPr>
           <a:xfrm>
-            <a:off x="1417320" y="8851392"/>
-            <a:ext cx="15453360" cy="274320"/>
+            <a:off x="3566160" y="9162288"/>
+            <a:ext cx="11155680" cy="310896"/>
           </a:xfrm>
           <a:prstGeom prst="roundRect">
             <a:avLst>
@@ -11270,6 +11270,28 @@
             </a:avLst>
           </a:prstGeom>
           <a:solidFill>
+            <a:srgbClr val="1A0044"/>
+          </a:solidFill>
+          <a:ln/>
+        </p:spPr>
+      </p:sp>
+      <p:sp>
+        <p:nvSpPr>
+          <p:cNvPr id="10" name="Shape 7"/>
+          <p:cNvSpPr/>
+          <p:nvPr/>
+        </p:nvSpPr>
+        <p:spPr>
+          <a:xfrm>
+            <a:off x="8503920" y="9253728"/>
+            <a:ext cx="1280160" cy="118872"/>
+          </a:xfrm>
+          <a:prstGeom prst="roundRect">
+            <a:avLst>
+              <a:gd name="adj" fmla="val 50000"/>
+            </a:avLst>
+          </a:prstGeom>
+          <a:solidFill>
             <a:srgbClr val="4A3570"/>
           </a:solidFill>
           <a:ln/>
@@ -11277,13 +11299,13 @@
       </p:sp>
       <p:sp>
         <p:nvSpPr>
-          <p:cNvPr id="10" name="Text 7"/>
-          <p:cNvSpPr/>
-          <p:nvPr/>
-        </p:nvSpPr>
-        <p:spPr>
-          <a:xfrm>
-            <a:off x="1280160" y="9372600"/>
+          <p:cNvPr id="11" name="Text 8"/>
+          <p:cNvSpPr/>
+          <p:nvPr/>
+        </p:nvSpPr>
+        <p:spPr>
+          <a:xfrm>
+            <a:off x="1280160" y="9601200"/>
             <a:ext cx="15727680" cy="411480"/>
           </a:xfrm>
           <a:prstGeom prst="rect">
@@ -11316,7 +11338,7 @@
       </p:sp>
       <p:sp>
         <p:nvSpPr>
-          <p:cNvPr id="11" name="Text 8"/>
+          <p:cNvPr id="12" name="Text 9"/>
           <p:cNvSpPr/>
           <p:nvPr/>
         </p:nvSpPr>
@@ -12035,23 +12057,45 @@
         </p:nvSpPr>
         <p:spPr>
           <a:xfrm>
-            <a:off x="10332720" y="2103120"/>
-            <a:ext cx="3063240" cy="6949440"/>
+            <a:off x="10561320" y="2182190"/>
+            <a:ext cx="2990088" cy="6078068"/>
           </a:xfrm>
           <a:prstGeom prst="roundRect">
             <a:avLst>
-              <a:gd name="adj" fmla="val 10746"/>
+              <a:gd name="adj" fmla="val 4281"/>
             </a:avLst>
           </a:prstGeom>
           <a:solidFill>
-            <a:srgbClr val="1A0044"/>
+            <a:srgbClr val="C8C6CE"/>
+          </a:solidFill>
+          <a:ln/>
+        </p:spPr>
+      </p:sp>
+      <p:sp>
+        <p:nvSpPr>
+          <p:cNvPr id="20" name="Shape 18"/>
+          <p:cNvSpPr/>
+          <p:nvPr/>
+        </p:nvSpPr>
+        <p:spPr>
+          <a:xfrm>
+            <a:off x="10611612" y="2232482"/>
+            <a:ext cx="2889504" cy="5977484"/>
+          </a:xfrm>
+          <a:prstGeom prst="roundRect">
+            <a:avLst>
+              <a:gd name="adj" fmla="val 4114"/>
+            </a:avLst>
+          </a:prstGeom>
+          <a:solidFill>
+            <a:srgbClr val="0B0B0F"/>
           </a:solidFill>
           <a:ln/>
         </p:spPr>
       </p:sp>
       <p:pic>
         <p:nvPicPr>
-          <p:cNvPr id="20" name="Image 0" descr="slide-mobile.png">    </p:cNvPr>
+          <p:cNvPr id="21" name="Image 0" descr="slide-mobile.png">    </p:cNvPr>
           <p:cNvPicPr>
             <a:picLocks noChangeAspect="1"/>
           </p:cNvPicPr>
@@ -12065,8 +12109,8 @@
         </p:blipFill>
         <p:spPr>
           <a:xfrm>
-            <a:off x="10451592" y="2267712"/>
-            <a:ext cx="2825496" cy="6620256"/>
+            <a:off x="10730484" y="2351354"/>
+            <a:ext cx="2651760" cy="5739740"/>
           </a:xfrm>
           <a:prstGeom prst="rect">
             <a:avLst/>
@@ -12075,29 +12119,161 @@
       </p:pic>
       <p:sp>
         <p:nvSpPr>
-          <p:cNvPr id="21" name="Shape 18"/>
-          <p:cNvSpPr/>
-          <p:nvPr/>
-        </p:nvSpPr>
-        <p:spPr>
-          <a:xfrm>
-            <a:off x="13761720" y="2103120"/>
-            <a:ext cx="3063240" cy="6949440"/>
+          <p:cNvPr id="22" name="Shape 19"/>
+          <p:cNvSpPr/>
+          <p:nvPr/>
+        </p:nvSpPr>
+        <p:spPr>
+          <a:xfrm>
+            <a:off x="11690604" y="2252599"/>
+            <a:ext cx="731520" cy="60350"/>
           </a:xfrm>
           <a:prstGeom prst="roundRect">
             <a:avLst>
-              <a:gd name="adj" fmla="val 10746"/>
+              <a:gd name="adj" fmla="val 50000"/>
             </a:avLst>
           </a:prstGeom>
           <a:solidFill>
-            <a:srgbClr val="1A0044"/>
+            <a:srgbClr val="2A2A32"/>
+          </a:solidFill>
+          <a:ln/>
+        </p:spPr>
+      </p:sp>
+      <p:sp>
+        <p:nvSpPr>
+          <p:cNvPr id="23" name="Shape 20"/>
+          <p:cNvSpPr/>
+          <p:nvPr/>
+        </p:nvSpPr>
+        <p:spPr>
+          <a:xfrm>
+            <a:off x="10529316" y="3142310"/>
+            <a:ext cx="45720" cy="256032"/>
+          </a:xfrm>
+          <a:prstGeom prst="roundRect">
+            <a:avLst>
+              <a:gd name="adj" fmla="val 50000"/>
+            </a:avLst>
+          </a:prstGeom>
+          <a:solidFill>
+            <a:srgbClr val="A9A7B0"/>
+          </a:solidFill>
+          <a:ln/>
+        </p:spPr>
+      </p:sp>
+      <p:sp>
+        <p:nvSpPr>
+          <p:cNvPr id="24" name="Shape 21"/>
+          <p:cNvSpPr/>
+          <p:nvPr/>
+        </p:nvSpPr>
+        <p:spPr>
+          <a:xfrm>
+            <a:off x="10529316" y="3553790"/>
+            <a:ext cx="45720" cy="438912"/>
+          </a:xfrm>
+          <a:prstGeom prst="roundRect">
+            <a:avLst>
+              <a:gd name="adj" fmla="val 50000"/>
+            </a:avLst>
+          </a:prstGeom>
+          <a:solidFill>
+            <a:srgbClr val="A9A7B0"/>
+          </a:solidFill>
+          <a:ln/>
+        </p:spPr>
+      </p:sp>
+      <p:sp>
+        <p:nvSpPr>
+          <p:cNvPr id="25" name="Shape 22"/>
+          <p:cNvSpPr/>
+          <p:nvPr/>
+        </p:nvSpPr>
+        <p:spPr>
+          <a:xfrm>
+            <a:off x="10529316" y="4120718"/>
+            <a:ext cx="45720" cy="438912"/>
+          </a:xfrm>
+          <a:prstGeom prst="roundRect">
+            <a:avLst>
+              <a:gd name="adj" fmla="val 50000"/>
+            </a:avLst>
+          </a:prstGeom>
+          <a:solidFill>
+            <a:srgbClr val="A9A7B0"/>
+          </a:solidFill>
+          <a:ln/>
+        </p:spPr>
+      </p:sp>
+      <p:sp>
+        <p:nvSpPr>
+          <p:cNvPr id="26" name="Shape 23"/>
+          <p:cNvSpPr/>
+          <p:nvPr/>
+        </p:nvSpPr>
+        <p:spPr>
+          <a:xfrm>
+            <a:off x="13537692" y="3754958"/>
+            <a:ext cx="45720" cy="640080"/>
+          </a:xfrm>
+          <a:prstGeom prst="roundRect">
+            <a:avLst>
+              <a:gd name="adj" fmla="val 50000"/>
+            </a:avLst>
+          </a:prstGeom>
+          <a:solidFill>
+            <a:srgbClr val="A9A7B0"/>
+          </a:solidFill>
+          <a:ln/>
+        </p:spPr>
+      </p:sp>
+      <p:sp>
+        <p:nvSpPr>
+          <p:cNvPr id="27" name="Shape 24"/>
+          <p:cNvSpPr/>
+          <p:nvPr/>
+        </p:nvSpPr>
+        <p:spPr>
+          <a:xfrm>
+            <a:off x="14127480" y="2182190"/>
+            <a:ext cx="2990088" cy="6078068"/>
+          </a:xfrm>
+          <a:prstGeom prst="roundRect">
+            <a:avLst>
+              <a:gd name="adj" fmla="val 4281"/>
+            </a:avLst>
+          </a:prstGeom>
+          <a:solidFill>
+            <a:srgbClr val="C8C6CE"/>
+          </a:solidFill>
+          <a:ln/>
+        </p:spPr>
+      </p:sp>
+      <p:sp>
+        <p:nvSpPr>
+          <p:cNvPr id="28" name="Shape 25"/>
+          <p:cNvSpPr/>
+          <p:nvPr/>
+        </p:nvSpPr>
+        <p:spPr>
+          <a:xfrm>
+            <a:off x="14177772" y="2232482"/>
+            <a:ext cx="2889504" cy="5977484"/>
+          </a:xfrm>
+          <a:prstGeom prst="roundRect">
+            <a:avLst>
+              <a:gd name="adj" fmla="val 4114"/>
+            </a:avLst>
+          </a:prstGeom>
+          <a:solidFill>
+            <a:srgbClr val="0B0B0F"/>
           </a:solidFill>
           <a:ln/>
         </p:spPr>
       </p:sp>
       <p:pic>
         <p:nvPicPr>
-          <p:cNvPr id="22" name="Image 1" descr="slide-mobile2.png">    </p:cNvPr>
+          <p:cNvPr id="29" name="Image 1" descr="slide-mobile2.png">    </p:cNvPr>
           <p:cNvPicPr>
             <a:picLocks noChangeAspect="1"/>
           </p:cNvPicPr>
@@ -12111,8 +12287,8 @@
         </p:blipFill>
         <p:spPr>
           <a:xfrm>
-            <a:off x="13880592" y="2267712"/>
-            <a:ext cx="2825496" cy="6620256"/>
+            <a:off x="14296644" y="2351354"/>
+            <a:ext cx="2651760" cy="5739740"/>
           </a:xfrm>
           <a:prstGeom prst="rect">
             <a:avLst/>
@@ -12121,7 +12297,117 @@
       </p:pic>
       <p:sp>
         <p:nvSpPr>
-          <p:cNvPr id="23" name="Text 19"/>
+          <p:cNvPr id="30" name="Shape 26"/>
+          <p:cNvSpPr/>
+          <p:nvPr/>
+        </p:nvSpPr>
+        <p:spPr>
+          <a:xfrm>
+            <a:off x="15256764" y="2252599"/>
+            <a:ext cx="731520" cy="60350"/>
+          </a:xfrm>
+          <a:prstGeom prst="roundRect">
+            <a:avLst>
+              <a:gd name="adj" fmla="val 50000"/>
+            </a:avLst>
+          </a:prstGeom>
+          <a:solidFill>
+            <a:srgbClr val="2A2A32"/>
+          </a:solidFill>
+          <a:ln/>
+        </p:spPr>
+      </p:sp>
+      <p:sp>
+        <p:nvSpPr>
+          <p:cNvPr id="31" name="Shape 27"/>
+          <p:cNvSpPr/>
+          <p:nvPr/>
+        </p:nvSpPr>
+        <p:spPr>
+          <a:xfrm>
+            <a:off x="14095476" y="3142310"/>
+            <a:ext cx="45720" cy="256032"/>
+          </a:xfrm>
+          <a:prstGeom prst="roundRect">
+            <a:avLst>
+              <a:gd name="adj" fmla="val 50000"/>
+            </a:avLst>
+          </a:prstGeom>
+          <a:solidFill>
+            <a:srgbClr val="A9A7B0"/>
+          </a:solidFill>
+          <a:ln/>
+        </p:spPr>
+      </p:sp>
+      <p:sp>
+        <p:nvSpPr>
+          <p:cNvPr id="32" name="Shape 28"/>
+          <p:cNvSpPr/>
+          <p:nvPr/>
+        </p:nvSpPr>
+        <p:spPr>
+          <a:xfrm>
+            <a:off x="14095476" y="3553790"/>
+            <a:ext cx="45720" cy="438912"/>
+          </a:xfrm>
+          <a:prstGeom prst="roundRect">
+            <a:avLst>
+              <a:gd name="adj" fmla="val 50000"/>
+            </a:avLst>
+          </a:prstGeom>
+          <a:solidFill>
+            <a:srgbClr val="A9A7B0"/>
+          </a:solidFill>
+          <a:ln/>
+        </p:spPr>
+      </p:sp>
+      <p:sp>
+        <p:nvSpPr>
+          <p:cNvPr id="33" name="Shape 29"/>
+          <p:cNvSpPr/>
+          <p:nvPr/>
+        </p:nvSpPr>
+        <p:spPr>
+          <a:xfrm>
+            <a:off x="14095476" y="4120718"/>
+            <a:ext cx="45720" cy="438912"/>
+          </a:xfrm>
+          <a:prstGeom prst="roundRect">
+            <a:avLst>
+              <a:gd name="adj" fmla="val 50000"/>
+            </a:avLst>
+          </a:prstGeom>
+          <a:solidFill>
+            <a:srgbClr val="A9A7B0"/>
+          </a:solidFill>
+          <a:ln/>
+        </p:spPr>
+      </p:sp>
+      <p:sp>
+        <p:nvSpPr>
+          <p:cNvPr id="34" name="Shape 30"/>
+          <p:cNvSpPr/>
+          <p:nvPr/>
+        </p:nvSpPr>
+        <p:spPr>
+          <a:xfrm>
+            <a:off x="17103852" y="3754958"/>
+            <a:ext cx="45720" cy="640080"/>
+          </a:xfrm>
+          <a:prstGeom prst="roundRect">
+            <a:avLst>
+              <a:gd name="adj" fmla="val 50000"/>
+            </a:avLst>
+          </a:prstGeom>
+          <a:solidFill>
+            <a:srgbClr val="A9A7B0"/>
+          </a:solidFill>
+          <a:ln/>
+        </p:spPr>
+      </p:sp>
+      <p:sp>
+        <p:nvSpPr>
+          <p:cNvPr id="35" name="Text 31"/>
           <p:cNvSpPr/>
           <p:nvPr/>
         </p:nvSpPr>

</xml_diff>